<commit_message>
Revert sweep charts to precision-recall frontier layout
The two-panel floor-on-x format was confusing in practice (lines cross on
some frames; the two scorings coincide on any_error). Back to precision vs
dollar recall with fixed comparable axes (y 0-0.6, x 0-1) and gray
99%-lower-bound floor labels on the points. Deck-embedded charts updated
to match.

Co-Authored-By: Claude Fable 5 <noreply@anthropic.com>
</commit_message>
<xml_diff>
--- a/how_to_use_the_snap_qc_inclusion_rules_scripts.pptx
+++ b/how_to_use_the_snap_qc_inclusion_rules_scripts.pptx
@@ -6862,15 +6862,15 @@
           <p:nvPr/>
         </p:nvPicPr>
         <p:blipFill>
-          <a:blip r:embed="rId3"/>
+          <a:blip r:embed="rId4"/>
           <a:stretch>
             <a:fillRect/>
           </a:stretch>
         </p:blipFill>
         <p:spPr>
           <a:xfrm>
-            <a:off x="1881200" y="1636350"/>
-            <a:ext cx="5381600" cy="2690800"/>
+            <a:off x="1881200" y="1300000"/>
+            <a:ext cx="5381600" cy="3363500"/>
           </a:xfrm>
           <a:prstGeom prst="rect">
             <a:avLst/>
@@ -7467,15 +7467,15 @@
           <p:nvPr/>
         </p:nvPicPr>
         <p:blipFill>
-          <a:blip r:embed="rId3"/>
+          <a:blip r:embed="rId4"/>
           <a:stretch>
             <a:fillRect/>
           </a:stretch>
         </p:blipFill>
         <p:spPr>
           <a:xfrm>
-            <a:off x="1881200" y="1636350"/>
-            <a:ext cx="5381600" cy="2690800"/>
+            <a:off x="1881200" y="1300000"/>
+            <a:ext cx="5381600" cy="3363500"/>
           </a:xfrm>
           <a:prstGeom prst="rect">
             <a:avLst/>

</xml_diff>

<commit_message>
Restore two-panel sweep chart format (floor on the x-axis)
Keep the two-chart layout with "99% lower bound precision" as the x-axis:
left panel hold-out precision, right panel hold-out share of error $
caught, lines compared vertically at the same floor. Deck-embedded charts
updated to match.

Co-Authored-By: Claude Fable 5 <noreply@anthropic.com>
</commit_message>
<xml_diff>
--- a/how_to_use_the_snap_qc_inclusion_rules_scripts.pptx
+++ b/how_to_use_the_snap_qc_inclusion_rules_scripts.pptx
@@ -6855,22 +6855,22 @@
       </p:sp>
       <p:pic>
         <p:nvPicPr>
-          <p:cNvPr id="5" name="Picture 4" descr="earned_income_lcb_sweep.png"/>
+          <p:cNvPr id="5" name="Picture 4" descr="image.png"/>
           <p:cNvPicPr>
             <a:picLocks noChangeAspect="1"/>
           </p:cNvPicPr>
           <p:nvPr/>
         </p:nvPicPr>
         <p:blipFill>
-          <a:blip r:embed="rId4"/>
+          <a:blip r:embed="rId3"/>
           <a:stretch>
             <a:fillRect/>
           </a:stretch>
         </p:blipFill>
         <p:spPr>
           <a:xfrm>
-            <a:off x="1881200" y="1300000"/>
-            <a:ext cx="5381600" cy="3363500"/>
+            <a:off x="1881200" y="1636350"/>
+            <a:ext cx="5381600" cy="2690800"/>
           </a:xfrm>
           <a:prstGeom prst="rect">
             <a:avLst/>
@@ -7460,22 +7460,22 @@
       </p:sp>
       <p:pic>
         <p:nvPicPr>
-          <p:cNvPr id="5" name="Picture 4" descr="other_error_lcb_sweep.png"/>
+          <p:cNvPr id="5" name="Picture 4" descr="image.png"/>
           <p:cNvPicPr>
             <a:picLocks noChangeAspect="1"/>
           </p:cNvPicPr>
           <p:nvPr/>
         </p:nvPicPr>
         <p:blipFill>
-          <a:blip r:embed="rId4"/>
+          <a:blip r:embed="rId3"/>
           <a:stretch>
             <a:fillRect/>
           </a:stretch>
         </p:blipFill>
         <p:spPr>
           <a:xfrm>
-            <a:off x="1881200" y="1300000"/>
-            <a:ext cx="5381600" cy="3363500"/>
+            <a:off x="1881200" y="1636350"/>
+            <a:ext cx="5381600" cy="2690800"/>
           </a:xfrm>
           <a:prstGeom prst="rect">
             <a:avLst/>

</xml_diff>

<commit_message>
Add floor-definition slide to how_to deck appendix
New slide 18 after "lucky rules, measured": the three-way floor comparison
figure with the overpromise/underpromise reading.

Co-Authored-By: Claude Fable 5 <noreply@anthropic.com>
</commit_message>
<xml_diff>
--- a/how_to_use_the_snap_qc_inclusion_rules_scripts.pptx
+++ b/how_to_use_the_snap_qc_inclusion_rules_scripts.pptx
@@ -25,6 +25,7 @@
     <p:sldId id="269" r:id="rId16"/>
     <p:sldId id="270" r:id="rId17"/>
     <p:sldId id="271" r:id="rId18"/>
+    <p:sldId id="278" r:id="rId24"/>
     <p:sldId id="272" r:id="rId19"/>
     <p:sldId id="273" r:id="rId20"/>
     <p:sldId id="274" r:id="rId21"/>
@@ -7597,6 +7598,140 @@
 </p:sld>
 </file>
 
+<file path=ppt/slides/slide22.xml><?xml version="1.0" encoding="utf-8"?>
+<p:sld xmlns:a="http://schemas.openxmlformats.org/drawingml/2006/main" xmlns:p="http://schemas.openxmlformats.org/presentationml/2006/main" xmlns:r="http://schemas.openxmlformats.org/officeDocument/2006/relationships">
+  <p:cSld>
+    <p:spTree>
+      <p:nvGrpSpPr>
+        <p:cNvPr id="1" name=""/>
+        <p:cNvGrpSpPr/>
+        <p:nvPr/>
+      </p:nvGrpSpPr>
+      <p:grpSpPr/>
+      <p:sp>
+        <p:nvSpPr>
+          <p:cNvPr id="2" name="TextBox 1"/>
+          <p:cNvSpPr txBox="1"/>
+          <p:nvPr/>
+        </p:nvSpPr>
+        <p:spPr>
+          <a:xfrm>
+            <a:off x="400000" y="200000"/>
+            <a:ext cx="8344000" cy="600000"/>
+          </a:xfrm>
+          <a:prstGeom prst="rect">
+            <a:avLst/>
+          </a:prstGeom>
+          <a:noFill/>
+        </p:spPr>
+        <p:txBody>
+          <a:bodyPr wrap="none">
+            <a:spAutoFit/>
+          </a:bodyPr>
+          <a:lstStyle/>
+          <a:p>
+            <a:r>
+              <a:rPr sz="2200" b="1"/>
+              <a:t>Appendix: why the menu axis is the lower bound, not raw trained precision</a:t>
+            </a:r>
+          </a:p>
+        </p:txBody>
+      </p:sp>
+      <p:sp>
+        <p:nvSpPr>
+          <p:cNvPr id="3" name="TextBox 2"/>
+          <p:cNvSpPr txBox="1"/>
+          <p:nvPr/>
+        </p:nvSpPr>
+        <p:spPr>
+          <a:xfrm>
+            <a:off x="400000" y="4723500"/>
+            <a:ext cx="3200000" cy="320000"/>
+          </a:xfrm>
+          <a:prstGeom prst="rect">
+            <a:avLst/>
+          </a:prstGeom>
+          <a:noFill/>
+        </p:spPr>
+        <p:txBody>
+          <a:bodyPr wrap="none">
+            <a:spAutoFit/>
+          </a:bodyPr>
+          <a:lstStyle/>
+          <a:p>
+            <a:r>
+              <a:rPr sz="1000" i="1"/>
+              <a:t>Appendix - v2 pipeline evidence</a:t>
+            </a:r>
+          </a:p>
+        </p:txBody>
+      </p:sp>
+      <p:sp>
+        <p:nvSpPr>
+          <p:cNvPr id="4" name="TextBox 3"/>
+          <p:cNvSpPr txBox="1"/>
+          <p:nvPr/>
+        </p:nvSpPr>
+        <p:spPr>
+          <a:xfrm>
+            <a:off x="400000" y="760000"/>
+            <a:ext cx="8344000" cy="430000"/>
+          </a:xfrm>
+          <a:prstGeom prst="rect">
+            <a:avLst/>
+          </a:prstGeom>
+          <a:noFill/>
+        </p:spPr>
+        <p:txBody>
+          <a:bodyPr wrap="square">
+            <a:spAutoFit/>
+          </a:bodyPr>
+          <a:lstStyle/>
+          <a:p>
+            <a:pPr>
+              <a:spcAft>
+                <a:spcPts val="400"/>
+              </a:spcAft>
+            </a:pPr>
+            <a:r>
+              <a:rPr sz="1200"/>
+              <a:t>- Same rules, three ways to set the floor. Floors on raw trained precision overpromise even after filtering: pick 0.50, get about 0.34 on a new year (middle column, below the grey line). Floors on the 99% lower bound underpromise: pick 0.30, get 0.38; pick 0.40, get 0.51 (right column, above the line). The menu axis is the lower bound because the number you pick is a promise the rules keep.</a:t>
+            </a:r>
+          </a:p>
+        </p:txBody>
+      </p:sp>
+      <p:pic>
+        <p:nvPicPr>
+          <p:cNvPr id="5" name="Picture 4" descr="floor_definitions_educational.png"/>
+          <p:cNvPicPr>
+            <a:picLocks noChangeAspect="1"/>
+          </p:cNvPicPr>
+          <p:nvPr/>
+        </p:nvPicPr>
+        <p:blipFill>
+          <a:blip r:embed="rId2"/>
+          <a:stretch>
+            <a:fillRect/>
+          </a:stretch>
+        </p:blipFill>
+        <p:spPr>
+          <a:xfrm>
+            <a:off x="2162556" y="1417320"/>
+            <a:ext cx="4818888" cy="3520440"/>
+          </a:xfrm>
+          <a:prstGeom prst="rect">
+            <a:avLst/>
+          </a:prstGeom>
+        </p:spPr>
+      </p:pic>
+    </p:spTree>
+  </p:cSld>
+  <p:clrMapOvr>
+    <a:masterClrMapping/>
+  </p:clrMapOvr>
+</p:sld>
+</file>
+
 <file path=ppt/slides/slide3.xml><?xml version="1.0" encoding="utf-8"?>
 <p:sld xmlns:a="http://schemas.openxmlformats.org/drawingml/2006/main" xmlns:r="http://schemas.openxmlformats.org/officeDocument/2006/relationships" xmlns:p="http://schemas.openxmlformats.org/presentationml/2006/main">
   <p:cSld>

</xml_diff>

<commit_message>
Decks: remove " - " dash connectors across all four decks (spareness pass)
Convert every " - " used as punctuation to spare, proper punctuation (period for
independent clauses, comma for asides, colon for label/explanation, parentheses for
interjections); standardize the two repeated footers to the title slide's middot.
Leading "- " list bullets are left alone. All edits are explicit, reviewable
unique-substring swaps in deck_style_pass.py; run-level so bold/italic is preserved.
Numbers verified byte-identical in every edited deck (lessons, inclusion, workshop).
other_error counts on inclusion s20 / lessons deferred as agreed (dash fixed, numbers
untouched). Result: 0 em-dashes and 0 internal dash-connectors in all four decks.

Co-Authored-By: Claude Opus 4.8 (1M context) <noreply@anthropic.com>
Claude-Session: https://claude.ai/code/session_01HZ1vRhTML3j5hwacjyDhJQ
</commit_message>
<xml_diff>
--- a/how_to_use_the_snap_qc_inclusion_rules_scripts.pptx
+++ b/how_to_use_the_snap_qc_inclusion_rules_scripts.pptx
@@ -5415,7 +5415,7 @@
           <a:p>
             <a:r>
               <a:rPr sz="1400" b="0" dirty="0"/>
-              <a:t>Every rule is then tested on a year of data that was never used for tuning - under both its adjusted cutoffs and the original national ones - and the whole exercise is compared against simply using the national rules unchanged. In seven-state testing, tuning helped when roughly 30+ rules met the bar (Connecticut: 43% of errors and 49% of error dollars caught, with about 1 in 5 flagged cases having an error) and hurt below that - with little data, tuning just rewards lucky cutoffs. Smaller states: use the national rules as-is.</a:t>
+              <a:t>Every rule is then tested on a year of data that was never used for tuning (under both its adjusted cutoffs and the original national ones), and the whole exercise is compared against simply using the national rules unchanged. In seven-state testing, tuning helped when roughly 30+ rules met the bar (Connecticut: 43% of errors and 49% of error dollars caught, with about 1 in 5 flagged cases having an error) and hurt below that; with little data, tuning just rewards lucky cutoffs. Smaller states: use the national rules as-is.</a:t>
             </a:r>
           </a:p>
           <a:p>
@@ -5727,7 +5727,7 @@
           <a:p>
             <a:r>
               <a:rPr sz="1000" i="1"/>
-              <a:t>Appendix - v2 pipeline evidence</a:t>
+              <a:t>Appendix: v2 pipeline evidence</a:t>
             </a:r>
           </a:p>
         </p:txBody>
@@ -5772,7 +5772,7 @@
             </a:pPr>
             <a:r>
               <a:rPr sz="1400" dirty="0"/>
-              <a:t>- The fix, by example: a rule that flagged 20 cases and was right 4 times and a rule that flagged 200 and was right 40 both measure 20% - but only the second has real evidence behind it. We adjust each rule's score for how much evidence it has, and keep a rule only when the adjusted score clears the bar.</a:t>
+              <a:t>- The fix, by example: a rule that flagged 20 cases and was right 4 times and a rule that flagged 200 and was right 40 both measure 20%, but only the second has real evidence behind it. We adjust each rule's score for how much evidence it has, and keep a rule only when the adjusted score clears the bar.</a:t>
             </a:r>
           </a:p>
           <a:p>
@@ -5783,7 +5783,7 @@
             </a:pPr>
             <a:r>
               <a:rPr sz="1400" dirty="0"/>
-              <a:t>- Result: kept rules deliver roughly what they promise on new data, and at the same delivered accuracy - about 1 in 5 flagged cases having an error - we catch 12.8% of all errors instead of 8.2%.</a:t>
+              <a:t>- Result: kept rules deliver roughly what they promise on new data, and at the same delivered accuracy (about 1 in 5 flagged cases having an error), we catch 12.8% of all errors instead of 8.2%.</a:t>
             </a:r>
           </a:p>
           <a:p>
@@ -5794,7 +5794,7 @@
             </a:pPr>
             <a:r>
               <a:rPr sz="1400" dirty="0"/>
-              <a:t>- Caution for single states: with only a few hundred errors to learn from, the adjustment alone is not enough - also require each rule to have flagged at least ~30 cases, or rules will still disappoint on new data.</a:t>
+              <a:t>- Caution for single states: with only a few hundred errors to learn from, the adjustment alone is not enough; also require each rule to have flagged at least ~30 cases, or rules will still disappoint on new data.</a:t>
             </a:r>
           </a:p>
         </p:txBody>
@@ -5877,7 +5877,7 @@
           <a:p>
             <a:r>
               <a:rPr sz="1000" i="1"/>
-              <a:t>Appendix - v2 pipeline evidence</a:t>
+              <a:t>Appendix: v2 pipeline evidence</a:t>
             </a:r>
           </a:p>
         </p:txBody>
@@ -5922,7 +5922,7 @@
             </a:pPr>
             <a:r>
               <a:rPr sz="1300" dirty="0"/>
-              <a:t>- Growing more trees does not make the kept rules more accurate - the two curves below sit on top of each other. It makes the MENU bigger: several times more rules pass any precision floor, so states have alternatives when their experts want to drop a rule.</a:t>
+              <a:t>- Growing more trees does not make the kept rules more accurate; the two curves below sit on top of each other. It makes the MENU bigger: several times more rules pass any precision floor, so states have alternatives when their experts want to drop a rule.</a:t>
             </a:r>
           </a:p>
           <a:p>
@@ -6011,7 +6011,7 @@
           <a:p>
             <a:r>
               <a:rPr sz="2200" b="1"/>
-              <a:t>Appendix: tuning detail - the boosted-tree method (xgboost)</a:t>
+              <a:t>Appendix: tuning detail for the boosted-tree method (xgboost)</a:t>
             </a:r>
           </a:p>
         </p:txBody>
@@ -6040,7 +6040,7 @@
           <a:p>
             <a:r>
               <a:rPr sz="1000" i="1"/>
-              <a:t>Appendix - v2 pipeline evidence</a:t>
+              <a:t>Appendix: v2 pipeline evidence</a:t>
             </a:r>
           </a:p>
         </p:txBody>
@@ -6163,7 +6163,7 @@
           <a:p>
             <a:r>
               <a:rPr sz="2200" b="1"/>
-              <a:t>Appendix: tuning detail - the random-forest method (ranger)</a:t>
+              <a:t>Appendix: tuning detail for the random-forest method (ranger)</a:t>
             </a:r>
           </a:p>
         </p:txBody>
@@ -6192,7 +6192,7 @@
           <a:p>
             <a:r>
               <a:rPr sz="1000" i="1"/>
-              <a:t>Appendix - v2 pipeline evidence</a:t>
+              <a:t>Appendix: v2 pipeline evidence</a:t>
             </a:r>
           </a:p>
         </p:txBody>
@@ -6226,7 +6226,7 @@
             </a:pPr>
             <a:r>
               <a:rPr sz="1200"/>
-              <a:t>- Letting each split choose between two variables beats forcing a single random variable - a little guidance beats pure randomness.</a:t>
+              <a:t>- Letting each split choose between two variables beats forcing a single random variable; a little guidance beats pure randomness.</a:t>
             </a:r>
           </a:p>
           <a:p>
@@ -6315,7 +6315,7 @@
           <a:p>
             <a:r>
               <a:rPr sz="2200" b="1"/>
-              <a:t>Appendix: tuning detail - how much data each tree sees</a:t>
+              <a:t>Appendix: tuning detail: how much data each tree sees</a:t>
             </a:r>
           </a:p>
         </p:txBody>
@@ -6344,7 +6344,7 @@
           <a:p>
             <a:r>
               <a:rPr sz="1000" i="1"/>
-              <a:t>Appendix - v2 pipeline evidence</a:t>
+              <a:t>Appendix: v2 pipeline evidence</a:t>
             </a:r>
           </a:p>
         </p:txBody>
@@ -6378,7 +6378,7 @@
             </a:pPr>
             <a:r>
               <a:rPr sz="1200"/>
-              <a:t>- Showing each tree a small random slice of the data (15-30%) works better than showing it most of the data (60-80%) - small slices make the trees more varied, and varied trees find sharper rules.</a:t>
+              <a:t>- Showing each tree a small random slice of the data (15-30%) works better than showing it most of the data (60-80%); small slices make the trees more varied, and varied trees find sharper rules.</a:t>
             </a:r>
           </a:p>
           <a:p>
@@ -6496,7 +6496,7 @@
           <a:p>
             <a:r>
               <a:rPr sz="1000" i="1"/>
-              <a:t>Appendix - v2 pipeline evidence</a:t>
+              <a:t>Appendix: v2 pipeline evidence</a:t>
             </a:r>
           </a:p>
         </p:txBody>
@@ -6653,7 +6653,7 @@
           <a:p>
             <a:r>
               <a:rPr sz="1000" i="1"/>
-              <a:t>Appendix - v2 pipeline evidence</a:t>
+              <a:t>Appendix: v2 pipeline evidence</a:t>
             </a:r>
           </a:p>
         </p:txBody>
@@ -6760,7 +6760,7 @@
           <a:p>
             <a:r>
               <a:rPr sz="1000" i="1"/>
-              <a:t>Appendix - v2 pipeline evidence</a:t>
+              <a:t>Appendix: v2 pipeline evidence</a:t>
             </a:r>
           </a:p>
         </p:txBody>
@@ -6794,7 +6794,7 @@
             </a:pPr>
             <a:r>
               <a:rPr sz="1200"/>
-              <a:t>- Rules built for specific error types and rules built on all errors together find different things - combining both catches 3-6 percentage points more errors at any precision floor, for a small accuracy cost. If you need just one simple model, the all-errors version gets you ~95% of the way.</a:t>
+              <a:t>- Rules built for specific error types and rules built on all errors together find different things; combining both catches 3-6 percentage points more errors at any precision floor, for a small accuracy cost. If you need just one simple model, the all-errors version gets you ~95% of the way.</a:t>
             </a:r>
           </a:p>
         </p:txBody>
@@ -7365,7 +7365,7 @@
           <a:p>
             <a:r>
               <a:rPr sz="1000" i="1"/>
-              <a:t>Appendix - v2 pipeline evidence</a:t>
+              <a:t>Appendix: v2 pipeline evidence</a:t>
             </a:r>
           </a:p>
         </p:txBody>
@@ -7399,7 +7399,7 @@
             </a:pPr>
             <a:r>
               <a:rPr sz="1200"/>
-              <a:t>- A rule built to find earned-income errors also flags cases with other kinds of errors - and those reviews succeed too. Counting only the intended error type, these rules score 8%; counting every error they actually catch, 19%. Report the second number - it is what reviewers will experience (dashed vs solid lines below).</a:t>
+              <a:t>- A rule built to find earned-income errors also flags cases with other kinds of errors, and those reviews succeed too. Counting only the intended error type, these rules score 8%; counting every error they actually catch, 19%. Report the second number: it is what reviewers will experience (dashed vs solid lines below).</a:t>
             </a:r>
           </a:p>
         </p:txBody>
@@ -7511,7 +7511,7 @@
           <a:p>
             <a:r>
               <a:rPr sz="1000" i="1"/>
-              <a:t>Appendix - v2 pipeline evidence</a:t>
+              <a:t>Appendix: v2 pipeline evidence</a:t>
             </a:r>
           </a:p>
         </p:txBody>
@@ -7545,7 +7545,7 @@
             </a:pPr>
             <a:r>
               <a:rPr sz="1200" dirty="0"/>
-              <a:t>- Errors in deductions, shelter costs, and household composition ('other') are the LARGEST error category - 2,007 of 4,460 errors in 2023. They turn out to be </a:t>
+              <a:t>- Errors in deductions, shelter costs, and household composition ('other') are the LARGEST error category: 2,007 of 4,460 errors in 2023. They turn out to be </a:t>
             </a:r>
             <a:r>
               <a:rPr lang="en-US" sz="1200" dirty="0"/>
@@ -7631,7 +7631,7 @@
           <a:p>
             <a:r>
               <a:rPr sz="2200" b="1" dirty="0"/>
-              <a:t>Appendix: elderly/disabled households - one model works for everyone</a:t>
+              <a:t>Appendix: elderly/disabled households: one model works for everyone</a:t>
             </a:r>
           </a:p>
         </p:txBody>
@@ -7660,7 +7660,7 @@
           <a:p>
             <a:r>
               <a:rPr sz="1000" i="1"/>
-              <a:t>Appendix - v2 pipeline evidence</a:t>
+              <a:t>Appendix: v2 pipeline evidence</a:t>
             </a:r>
           </a:p>
         </p:txBody>
@@ -7932,7 +7932,7 @@
                 <a:cs typeface="Arial"/>
                 <a:sym typeface="Arial"/>
               </a:rPr>
-              <a:t>Finding rules - </a:t>
+              <a:t>Finding rules: </a:t>
             </a:r>
             <a:r>
               <a:rPr lang="en-US" sz="1450" dirty="0">
@@ -7981,7 +7981,7 @@
                 <a:cs typeface="Arial"/>
                 <a:sym typeface="Arial"/>
               </a:rPr>
-              <a:t>Keeping rules </a:t>
+              <a:t>Keeping rules: </a:t>
             </a:r>
             <a:r>
               <a:rPr lang="en-US" sz="1450" dirty="0">
@@ -7993,7 +7993,7 @@
                 <a:cs typeface="Arial"/>
                 <a:sym typeface="Arial"/>
               </a:rPr>
-              <a:t>- a rule tested on only a handful of cases can look great by luck. Before keeping a rule, we shrink its measured precision to what we can be statistically confident of, given how many cases it was tested on. Without this step, a rule list promising 20% precision delivered about 10% on new data.</a:t>
+              <a:t>a rule tested on only a handful of cases can look great by luck. Before keeping a rule, we shrink its measured precision to what we can be statistically confident of, given how many cases it was tested on. Without this step, a rule list promising 20% precision delivered about 10% on new data.</a:t>
             </a:r>
             <a:endParaRPr sz="1450" dirty="0">
               <a:solidFill>
@@ -8030,7 +8030,7 @@
                 <a:cs typeface="Arial"/>
                 <a:sym typeface="Arial"/>
               </a:rPr>
-              <a:t>By household size </a:t>
+              <a:t>By household size: </a:t>
             </a:r>
             <a:r>
               <a:rPr lang="en-US" sz="1450" dirty="0">
@@ -8042,7 +8042,7 @@
                 <a:cs typeface="Arial"/>
                 <a:sym typeface="Arial"/>
               </a:rPr>
-              <a:t>- cases are split into sizes 1, 2-3, and 4+ and modeled separately, since benefits and error amounts scale with household size.</a:t>
+              <a:t>cases are split into sizes 1, 2-3, and 4+ and modeled separately, since benefits and error amounts scale with household size.</a:t>
             </a:r>
             <a:endParaRPr sz="1450" dirty="0">
               <a:solidFill>
@@ -8091,7 +8091,7 @@
                 <a:cs typeface="Arial"/>
                 <a:sym typeface="Arial"/>
               </a:rPr>
-              <a:t> - when a flagged case turns out to have a different kind of error than the rule was built for, the review still succeeded. Counting only the original error type understates real-world accuracy by about half.</a:t>
+              <a:t>: when a flagged case turns out to have a different kind of error than the rule was built for, the review still succeeded. Counting only the original error type understates real-world accuracy by about half.</a:t>
             </a:r>
             <a:endParaRPr sz="1450" dirty="0">
               <a:solidFill>
@@ -8361,7 +8361,7 @@
             </a:r>
             <a:r>
               <a:rPr sz="1300" dirty="0"/>
-              <a:t>beats either engine alone - </a:t>
+              <a:t>beats either engine alone; </a:t>
             </a:r>
             <a:r>
               <a:rPr lang="en-US" sz="1300" dirty="0"/>
@@ -10719,7 +10719,7 @@
             </a:r>
             <a:r>
               <a:rPr lang="en-US" sz="1200" dirty="0"/>
-              <a:t>: Track, for each level of precision, what ALL the selected rules achieve together - how many cases they flag and what share of errors and error dollars they catch (a case flagged by several rules counts once).</a:t>
+              <a:t>: Track, for each level of precision, what ALL the selected rules achieve together: how many cases they flag and what share of errors and error dollars they catch (a case flagged by several rules counts once).</a:t>
             </a:r>
             <a:endParaRPr sz="1200" dirty="0"/>
           </a:p>

</xml_diff>